<commit_message>
Rebuild all decks in the Midnight Copper design with the official logo and Russian versions
All six decks now share lib2.js (navy/ivory/copper theme), carry the
firm's official logo on the cover and footer, and are delivered in
Arabic, English and Russian. Russian text for decks 1–5 comes from
ru.json keyed by the English string.

Co-Authored-By: Claude Fable 5.1 <noreply@anthropic.com>
Claude-Session: https://claude.ai/code/session_016iqXZoJfFPSeJnjhoiAqom
</commit_message>
<xml_diff>
--- a/presentations/02_Brokerage_Owners_Executive_Brief_AR.pptx
+++ b/presentations/02_Brokerage_Owners_Executive_Brief_AR.pptx
@@ -117,7 +117,7 @@
   <p:extLst>
     <p:ext uri="{521415D9-36F7-43E2-AB2F-B90AF26B5E84}">
       <p14:sectionLst xmlns:p14="http://schemas.microsoft.com/office/powerpoint/2010/main">
-        <p14:section name="العرض" id="{c5cf428a-bdb7-6311-a24b-69b30c848a07}">
+        <p14:section name="العرض" id="{0963b124-c0ae-b1ab-2cc7-8936cc36c10f}">
           <p14:sldIdLst>
             <p14:sldId id="256"/>
             <p14:sldId id="257"/>
@@ -1494,7 +1494,7 @@
     <p:bg>
       <p:bgPr>
         <a:solidFill>
-          <a:srgbClr val="0B0B0B"/>
+          <a:srgbClr val="0E2238"/>
         </a:solidFill>
       </p:bgPr>
     </p:bg>
@@ -1512,106 +1512,30 @@
           <a:chExt cx="0" cy="0"/>
         </a:xfrm>
       </p:grpSpPr>
-      <p:sp>
-        <p:nvSpPr>
-          <p:cNvPr id="2" name="Shape 0"/>
-          <p:cNvSpPr/>
-          <p:nvPr/>
-        </p:nvSpPr>
-        <p:spPr>
-          <a:xfrm>
-            <a:off x="8394192" y="4626864"/>
-            <a:ext cx="384048" cy="384048"/>
-          </a:xfrm>
-          <a:prstGeom prst="rect">
-            <a:avLst/>
-          </a:prstGeom>
-          <a:solidFill>
-            <a:srgbClr val="0B0B0B"/>
-          </a:solidFill>
-          <a:ln w="9525">
-            <a:solidFill>
-              <a:srgbClr val="B08D57"/>
-            </a:solidFill>
-            <a:prstDash val="solid"/>
-          </a:ln>
-        </p:spPr>
-      </p:sp>
-      <p:sp>
-        <p:nvSpPr>
-          <p:cNvPr id="3" name="Text 1"/>
-          <p:cNvSpPr/>
-          <p:nvPr/>
-        </p:nvSpPr>
-        <p:spPr>
-          <a:xfrm>
-            <a:off x="8394192" y="4626864"/>
-            <a:ext cx="384048" cy="384048"/>
-          </a:xfrm>
-          <a:prstGeom prst="rect">
-            <a:avLst/>
-          </a:prstGeom>
-          <a:noFill/>
-          <a:ln/>
-        </p:spPr>
-        <p:txBody>
-          <a:bodyPr wrap="square" lIns="0" tIns="0" rIns="0" bIns="0" rtlCol="0" anchor="ctr"/>
-          <a:lstStyle/>
-          <a:p>
-            <a:pPr algn="ctr" indent="0" marL="0">
-              <a:buNone/>
-            </a:pPr>
-            <a:r>
-              <a:rPr lang="en-US" sz="1000" b="1" dirty="0">
-                <a:solidFill>
-                  <a:srgbClr val="B08D57"/>
-                </a:solidFill>
-                <a:latin typeface="Cambria" pitchFamily="34" charset="0"/>
-                <a:ea typeface="Cambria" pitchFamily="34" charset="-122"/>
-                <a:cs typeface="Cambria" pitchFamily="34" charset="-120"/>
-              </a:rPr>
-              <a:t>RK</a:t>
-            </a:r>
-            <a:endParaRPr lang="en-US" sz="1000" dirty="0"/>
-          </a:p>
-        </p:txBody>
-      </p:sp>
-      <p:sp>
-        <p:nvSpPr>
-          <p:cNvPr id="4" name="Text 2"/>
-          <p:cNvSpPr/>
-          <p:nvPr/>
-        </p:nvSpPr>
-        <p:spPr>
-          <a:xfrm>
-            <a:off x="3200400" y="4626864"/>
-            <a:ext cx="5120640" cy="384048"/>
-          </a:xfrm>
-          <a:prstGeom prst="rect">
-            <a:avLst/>
-          </a:prstGeom>
-          <a:noFill/>
-          <a:ln/>
-        </p:spPr>
-        <p:txBody>
-          <a:bodyPr wrap="square" lIns="0" tIns="0" rIns="0" bIns="0" rtlCol="0" anchor="ctr"/>
-          <a:lstStyle/>
-          <a:p>
-            <a:pPr algn="r" indent="0" marL="0">
-              <a:buNone/>
-            </a:pPr>
-            <a:r>
-              <a:rPr lang="en-US" sz="900" dirty="0">
-                <a:solidFill>
-                  <a:srgbClr val="D8C39A"/>
-                </a:solidFill>
-              </a:rPr>
-              <a:t>راشد الكيتوب للمحاماة والاستشارات القانونية</a:t>
-            </a:r>
-            <a:endParaRPr lang="en-US" sz="900" dirty="0"/>
-          </a:p>
-        </p:txBody>
-      </p:sp>
+      <p:pic>
+        <p:nvPicPr>
+          <p:cNvPr id="2" name="Image 0" descr="/tmp/claude-0/-home-user-aa/b81485da-2e22-5d10-878f-01904e6d5dc6/scratchpad/rk/logo_dark.png">    </p:cNvPr>
+          <p:cNvPicPr>
+            <a:picLocks noChangeAspect="1"/>
+          </p:cNvPicPr>
+          <p:nvPr/>
+        </p:nvPicPr>
+        <p:blipFill>
+          <a:blip r:embed="rId1"/>
+          <a:stretch>
+            <a:fillRect/>
+          </a:stretch>
+        </p:blipFill>
+        <p:spPr>
+          <a:xfrm>
+            <a:off x="7102823" y="4681728"/>
+            <a:ext cx="1675417" cy="274320"/>
+          </a:xfrm>
+          <a:prstGeom prst="rect">
+            <a:avLst/>
+          </a:prstGeom>
+        </p:spPr>
+      </p:pic>
       <p:sp>
         <p:nvSpPr>
           <p:cNvPr id="25" name="Slide Number Placeholder 0"/>
@@ -1642,7 +1566,7 @@
             <a:lvl1pPr>
               <a:defRPr sz="900">
                 <a:solidFill>
-                  <a:srgbClr val="D8C39A"/>
+                  <a:srgbClr val="D9B38C"/>
                 </a:solidFill>
               </a:defRPr>
             </a:lvl1pPr>
@@ -1689,118 +1613,42 @@
           <a:chExt cx="0" cy="0"/>
         </a:xfrm>
       </p:grpSpPr>
-      <p:sp>
-        <p:nvSpPr>
-          <p:cNvPr id="2" name="Shape 0"/>
-          <p:cNvSpPr/>
-          <p:nvPr/>
-        </p:nvSpPr>
-        <p:spPr>
-          <a:xfrm>
-            <a:off x="8394192" y="4626864"/>
-            <a:ext cx="384048" cy="384048"/>
-          </a:xfrm>
-          <a:prstGeom prst="rect">
-            <a:avLst/>
-          </a:prstGeom>
-          <a:solidFill>
-            <a:srgbClr val="FFFFFF"/>
-          </a:solidFill>
-          <a:ln w="9525">
-            <a:solidFill>
-              <a:srgbClr val="B08D57"/>
-            </a:solidFill>
-            <a:prstDash val="solid"/>
-          </a:ln>
-        </p:spPr>
-      </p:sp>
-      <p:sp>
-        <p:nvSpPr>
-          <p:cNvPr id="3" name="Text 1"/>
-          <p:cNvSpPr/>
-          <p:nvPr/>
-        </p:nvSpPr>
-        <p:spPr>
-          <a:xfrm>
-            <a:off x="8394192" y="4626864"/>
-            <a:ext cx="384048" cy="384048"/>
-          </a:xfrm>
-          <a:prstGeom prst="rect">
-            <a:avLst/>
-          </a:prstGeom>
-          <a:noFill/>
-          <a:ln/>
-        </p:spPr>
-        <p:txBody>
-          <a:bodyPr wrap="square" lIns="0" tIns="0" rIns="0" bIns="0" rtlCol="0" anchor="ctr"/>
-          <a:lstStyle/>
-          <a:p>
-            <a:pPr algn="ctr" indent="0" marL="0">
-              <a:buNone/>
-            </a:pPr>
-            <a:r>
-              <a:rPr lang="en-US" sz="1000" b="1" dirty="0">
-                <a:solidFill>
-                  <a:srgbClr val="B08D57"/>
-                </a:solidFill>
-                <a:latin typeface="Cambria" pitchFamily="34" charset="0"/>
-                <a:ea typeface="Cambria" pitchFamily="34" charset="-122"/>
-                <a:cs typeface="Cambria" pitchFamily="34" charset="-120"/>
-              </a:rPr>
-              <a:t>RK</a:t>
-            </a:r>
-            <a:endParaRPr lang="en-US" sz="1000" dirty="0"/>
-          </a:p>
-        </p:txBody>
-      </p:sp>
-      <p:sp>
-        <p:nvSpPr>
-          <p:cNvPr id="4" name="Text 2"/>
-          <p:cNvSpPr/>
-          <p:nvPr/>
-        </p:nvSpPr>
-        <p:spPr>
-          <a:xfrm>
-            <a:off x="3200400" y="4626864"/>
-            <a:ext cx="5120640" cy="384048"/>
-          </a:xfrm>
-          <a:prstGeom prst="rect">
-            <a:avLst/>
-          </a:prstGeom>
-          <a:noFill/>
-          <a:ln/>
-        </p:spPr>
-        <p:txBody>
-          <a:bodyPr wrap="square" lIns="0" tIns="0" rIns="0" bIns="0" rtlCol="0" anchor="ctr"/>
-          <a:lstStyle/>
-          <a:p>
-            <a:pPr algn="r" indent="0" marL="0">
-              <a:buNone/>
-            </a:pPr>
-            <a:r>
-              <a:rPr lang="en-US" sz="900" dirty="0">
-                <a:solidFill>
-                  <a:srgbClr val="6B6F76"/>
-                </a:solidFill>
-              </a:rPr>
-              <a:t>راشد الكيتوب للمحاماة والاستشارات القانونية</a:t>
-            </a:r>
-            <a:endParaRPr lang="en-US" sz="900" dirty="0"/>
-          </a:p>
-        </p:txBody>
-      </p:sp>
-      <p:sp>
-        <p:nvSpPr>
-          <p:cNvPr id="5" name="Text 3"/>
+      <p:pic>
+        <p:nvPicPr>
+          <p:cNvPr id="2" name="Image 0" descr="/tmp/claude-0/-home-user-aa/b81485da-2e22-5d10-878f-01904e6d5dc6/scratchpad/rk/logo_light.png">    </p:cNvPr>
+          <p:cNvPicPr>
+            <a:picLocks noChangeAspect="1"/>
+          </p:cNvPicPr>
+          <p:nvPr/>
+        </p:nvPicPr>
+        <p:blipFill>
+          <a:blip r:embed="rId1"/>
+          <a:stretch>
+            <a:fillRect/>
+          </a:stretch>
+        </p:blipFill>
+        <p:spPr>
+          <a:xfrm>
+            <a:off x="7102823" y="4681728"/>
+            <a:ext cx="1675417" cy="274320"/>
+          </a:xfrm>
+          <a:prstGeom prst="rect">
+            <a:avLst/>
+          </a:prstGeom>
+        </p:spPr>
+      </p:pic>
+      <p:sp>
+        <p:nvSpPr>
+          <p:cNvPr id="3" name="Text 0"/>
           <p:cNvSpPr/>
           <p:nvPr>
-            <p:ph idx="103" type="title" hasCustomPrompt="1"/>
+            <p:ph idx="101" type="title" hasCustomPrompt="1"/>
           </p:nvPr>
         </p:nvSpPr>
         <p:spPr>
           <a:xfrm>
-            <a:off x="457200" y="347472"/>
-            <a:ext cx="8229600" cy="685800"/>
+            <a:off x="457200" y="420624"/>
+            <a:ext cx="8229600" cy="731520"/>
           </a:xfrm>
           <a:prstGeom prst="rect">
             <a:avLst/>
@@ -1815,7 +1663,7 @@
               <a:buNone/>
               <a:defRPr lang="en-US" sz="2600" b="1" dirty="0">
                 <a:solidFill>
-                  <a:srgbClr val="0B0B0B"/>
+                  <a:srgbClr val="0E2238"/>
                 </a:solidFill>
               </a:defRPr>
             </a:lvl1pPr>
@@ -1858,7 +1706,7 @@
             <a:lvl1pPr>
               <a:defRPr sz="900">
                 <a:solidFill>
-                  <a:srgbClr val="6B6F76"/>
+                  <a:srgbClr val="6E7B88"/>
                 </a:solidFill>
               </a:defRPr>
             </a:lvl1pPr>
@@ -1887,7 +1735,7 @@
     <p:bg>
       <p:bgPr>
         <a:solidFill>
-          <a:srgbClr val="0B0B0B"/>
+          <a:srgbClr val="0E2238"/>
         </a:solidFill>
       </p:bgPr>
     </p:bg>
@@ -1960,7 +1808,7 @@
             <a:lvl1pPr>
               <a:defRPr sz="900">
                 <a:solidFill>
-                  <a:srgbClr val="D8C39A"/>
+                  <a:srgbClr val="D9B38C"/>
                 </a:solidFill>
               </a:defRPr>
             </a:lvl1pPr>
@@ -2271,47 +2119,46 @@
           </a:prstGeom>
           <a:ln w="9525">
             <a:solidFill>
-              <a:srgbClr val="B08D57"/>
+              <a:srgbClr val="B5723B"/>
             </a:solidFill>
             <a:prstDash val="solid"/>
           </a:ln>
         </p:spPr>
       </p:sp>
-      <p:sp>
-        <p:nvSpPr>
-          <p:cNvPr id="3" name="Shape 1"/>
-          <p:cNvSpPr/>
-          <p:nvPr/>
-        </p:nvSpPr>
-        <p:spPr>
-          <a:xfrm>
-            <a:off x="7452360" y="868680"/>
-            <a:ext cx="822960" cy="822960"/>
-          </a:xfrm>
-          <a:prstGeom prst="rect">
-            <a:avLst/>
-          </a:prstGeom>
-          <a:solidFill>
-            <a:srgbClr val="0B0B0B"/>
-          </a:solidFill>
-          <a:ln w="12700">
-            <a:solidFill>
-              <a:srgbClr val="B08D57"/>
-            </a:solidFill>
-            <a:prstDash val="solid"/>
-          </a:ln>
-        </p:spPr>
-      </p:sp>
-      <p:sp>
-        <p:nvSpPr>
-          <p:cNvPr id="4" name="Text 2"/>
+      <p:pic>
+        <p:nvPicPr>
+          <p:cNvPr id="3" name="Image 0" descr="/tmp/claude-0/-home-user-aa/b81485da-2e22-5d10-878f-01904e6d5dc6/scratchpad/rk/logo_dark.png">    </p:cNvPr>
+          <p:cNvPicPr>
+            <a:picLocks noChangeAspect="1"/>
+          </p:cNvPicPr>
+          <p:nvPr/>
+        </p:nvPicPr>
+        <p:blipFill>
+          <a:blip r:embed="rId1"/>
+          <a:stretch>
+            <a:fillRect/>
+          </a:stretch>
+        </p:blipFill>
+        <p:spPr>
+          <a:xfrm>
+            <a:off x="4254320" y="868680"/>
+            <a:ext cx="4021000" cy="658368"/>
+          </a:xfrm>
+          <a:prstGeom prst="rect">
+            <a:avLst/>
+          </a:prstGeom>
+        </p:spPr>
+      </p:pic>
+      <p:sp>
+        <p:nvSpPr>
+          <p:cNvPr id="4" name="Text 1"/>
           <p:cNvSpPr txBox="1"/>
           <p:nvPr/>
         </p:nvSpPr>
         <p:spPr>
           <a:xfrm>
-            <a:off x="7452360" y="868680"/>
-            <a:ext cx="822960" cy="822960"/>
+            <a:off x="868680" y="1965960"/>
+            <a:ext cx="7406640" cy="1371600"/>
           </a:xfrm>
           <a:prstGeom prst="rect">
             <a:avLst/>
@@ -2323,93 +2170,18 @@
           <a:bodyPr wrap="square" lIns="0" tIns="0" rIns="0" bIns="0" rtlCol="0" anchor="ctr"/>
           <a:lstStyle/>
           <a:p>
-            <a:pPr algn="ctr" indent="0" marL="0">
-              <a:buNone/>
-            </a:pPr>
-            <a:r>
-              <a:rPr lang="en-US" sz="2400" b="1" dirty="0">
-                <a:solidFill>
-                  <a:schemeClr val="accent1"/>
+            <a:pPr rtl="1" algn="r" indent="0" marL="0">
+              <a:buNone/>
+            </a:pPr>
+            <a:r>
+              <a:rPr lang="ar-AE" altLang="en-US" sz="3400" b="1" dirty="0">
+                <a:solidFill>
+                  <a:schemeClr val="bg1"/>
                 </a:solidFill>
                 <a:latin typeface="Cambria" pitchFamily="34" charset="0"/>
                 <a:ea typeface="Cambria" pitchFamily="34" charset="-122"/>
                 <a:cs typeface="Cambria" pitchFamily="34" charset="-120"/>
               </a:rPr>
-              <a:t>RK</a:t>
-            </a:r>
-            <a:endParaRPr lang="en-US" sz="2400" dirty="0"/>
-          </a:p>
-        </p:txBody>
-      </p:sp>
-      <p:sp>
-        <p:nvSpPr>
-          <p:cNvPr id="5" name="Text 3"/>
-          <p:cNvSpPr txBox="1"/>
-          <p:nvPr/>
-        </p:nvSpPr>
-        <p:spPr>
-          <a:xfrm>
-            <a:off x="1325880" y="868680"/>
-            <a:ext cx="5943600" cy="822960"/>
-          </a:xfrm>
-          <a:prstGeom prst="rect">
-            <a:avLst/>
-          </a:prstGeom>
-          <a:noFill/>
-          <a:ln/>
-        </p:spPr>
-        <p:txBody>
-          <a:bodyPr wrap="square" lIns="0" tIns="0" rIns="0" bIns="0" rtlCol="0" anchor="ctr"/>
-          <a:lstStyle/>
-          <a:p>
-            <a:pPr rtl="1" algn="r" indent="0" marL="0">
-              <a:buNone/>
-            </a:pPr>
-            <a:r>
-              <a:rPr lang="ar-AE" altLang="en-US" sz="1200" dirty="0">
-                <a:solidFill>
-                  <a:schemeClr val="accent2"/>
-                </a:solidFill>
-              </a:rPr>
-              <a:t>راشد الكيتوب للمحاماة والاستشارات القانونية</a:t>
-            </a:r>
-            <a:endParaRPr lang="ar-AE" sz="1200" dirty="0"/>
-          </a:p>
-        </p:txBody>
-      </p:sp>
-      <p:sp>
-        <p:nvSpPr>
-          <p:cNvPr id="6" name="Text 4"/>
-          <p:cNvSpPr txBox="1"/>
-          <p:nvPr/>
-        </p:nvSpPr>
-        <p:spPr>
-          <a:xfrm>
-            <a:off x="868680" y="1965960"/>
-            <a:ext cx="7406640" cy="1371600"/>
-          </a:xfrm>
-          <a:prstGeom prst="rect">
-            <a:avLst/>
-          </a:prstGeom>
-          <a:noFill/>
-          <a:ln/>
-        </p:spPr>
-        <p:txBody>
-          <a:bodyPr wrap="square" lIns="0" tIns="0" rIns="0" bIns="0" rtlCol="0" anchor="ctr"/>
-          <a:lstStyle/>
-          <a:p>
-            <a:pPr rtl="1" algn="r" indent="0" marL="0">
-              <a:buNone/>
-            </a:pPr>
-            <a:r>
-              <a:rPr lang="ar-AE" altLang="en-US" sz="3400" b="1" dirty="0">
-                <a:solidFill>
-                  <a:schemeClr val="bg1"/>
-                </a:solidFill>
-                <a:latin typeface="Cambria" pitchFamily="34" charset="0"/>
-                <a:ea typeface="Cambria" pitchFamily="34" charset="-122"/>
-                <a:cs typeface="Cambria" pitchFamily="34" charset="-120"/>
-              </a:rPr>
               <a:t>شراكة الحماية القانونية للمستثمرين</a:t>
             </a:r>
             <a:endParaRPr lang="ar-AE" sz="3400" dirty="0"/>
@@ -2418,7 +2190,7 @@
       </p:sp>
       <p:sp>
         <p:nvSpPr>
-          <p:cNvPr id="7" name="Text 5"/>
+          <p:cNvPr id="5" name="Text 2"/>
           <p:cNvSpPr txBox="1"/>
           <p:nvPr/>
         </p:nvSpPr>
@@ -2454,7 +2226,7 @@
       </p:sp>
       <p:sp>
         <p:nvSpPr>
-          <p:cNvPr id="8" name="Text 6"/>
+          <p:cNvPr id="6" name="Text 3"/>
           <p:cNvSpPr txBox="1"/>
           <p:nvPr/>
         </p:nvSpPr>
@@ -2518,7 +2290,7 @@
             <a:lvl1pPr>
               <a:defRPr sz="900">
                 <a:solidFill>
-                  <a:srgbClr val="D8C39A"/>
+                  <a:srgbClr val="D9B38C"/>
                 </a:solidFill>
               </a:defRPr>
             </a:lvl1pPr>
@@ -2574,7 +2346,7 @@
           </a:prstGeom>
           <a:ln w="9525">
             <a:solidFill>
-              <a:srgbClr val="B08D57"/>
+              <a:srgbClr val="B5723B"/>
             </a:solidFill>
             <a:prstDash val="solid"/>
           </a:ln>
@@ -2724,7 +2496,7 @@
             <a:lvl1pPr>
               <a:defRPr sz="900">
                 <a:solidFill>
-                  <a:srgbClr val="D8C39A"/>
+                  <a:srgbClr val="D9B38C"/>
                 </a:solidFill>
               </a:defRPr>
             </a:lvl1pPr>
@@ -2780,7 +2552,7 @@
           </a:prstGeom>
           <a:ln w="9525">
             <a:solidFill>
-              <a:srgbClr val="B08D57"/>
+              <a:srgbClr val="B5723B"/>
             </a:solidFill>
             <a:prstDash val="solid"/>
           </a:ln>
@@ -3103,42 +2875,6 @@
       </p:sp>
       <p:sp>
         <p:nvSpPr>
-          <p:cNvPr id="13" name="Text 7"/>
-          <p:cNvSpPr txBox="1"/>
-          <p:nvPr/>
-        </p:nvSpPr>
-        <p:spPr>
-          <a:xfrm>
-            <a:off x="868680" y="4206240"/>
-            <a:ext cx="7406640" cy="365760"/>
-          </a:xfrm>
-          <a:prstGeom prst="rect">
-            <a:avLst/>
-          </a:prstGeom>
-          <a:noFill/>
-          <a:ln/>
-        </p:spPr>
-        <p:txBody>
-          <a:bodyPr wrap="square" lIns="0" tIns="0" rIns="0" bIns="0" rtlCol="0" anchor="ctr"/>
-          <a:lstStyle/>
-          <a:p>
-            <a:pPr rtl="1" algn="r" indent="0" marL="0">
-              <a:buNone/>
-            </a:pPr>
-            <a:r>
-              <a:rPr lang="ar-AE" altLang="en-US" sz="1000" dirty="0">
-                <a:solidFill>
-                  <a:schemeClr val="accent1"/>
-                </a:solidFill>
-              </a:rPr>
-              <a:t>راشد الكيتوب للمحاماة والاستشارات القانونية</a:t>
-            </a:r>
-            <a:endParaRPr lang="ar-AE" sz="1000" dirty="0"/>
-          </a:p>
-        </p:txBody>
-      </p:sp>
-      <p:sp>
-        <p:nvSpPr>
           <p:cNvPr id="25" name="Slide Number Placeholder 0"/>
           <p:cNvSpPr>
             <a:spLocks noGrp="1"/>
@@ -3167,7 +2903,7 @@
             <a:lvl1pPr>
               <a:defRPr sz="900">
                 <a:solidFill>
-                  <a:srgbClr val="D8C39A"/>
+                  <a:srgbClr val="D9B38C"/>
                 </a:solidFill>
               </a:defRPr>
             </a:lvl1pPr>
@@ -3209,39 +2945,40 @@
       </p:grpSpPr>
       <p:sp>
         <p:nvSpPr>
-          <p:cNvPr id="2" name="Text 3"/>
-          <p:cNvSpPr/>
-          <p:nvPr>
-            <p:ph idx="103" type="title" hasCustomPrompt="1"/>
-          </p:nvPr>
-        </p:nvSpPr>
-        <p:spPr>
-          <a:xfrm>
-            <a:off x="457200" y="347472"/>
-            <a:ext cx="8229600" cy="685800"/>
-          </a:xfrm>
-          <a:prstGeom prst="rect">
-            <a:avLst/>
-          </a:prstGeom>
-          <a:noFill/>
-          <a:ln/>
-        </p:spPr>
-        <p:txBody>
-          <a:bodyPr wrap="square" lIns="0" tIns="0" rIns="0" bIns="0" rtlCol="0" anchor="ctr"/>
+          <p:cNvPr id="2" name="Text 0"/>
+          <p:cNvSpPr txBox="1"/>
+          <p:nvPr/>
+        </p:nvSpPr>
+        <p:spPr>
+          <a:xfrm>
+            <a:off x="457200" y="402336"/>
+            <a:ext cx="8229600" cy="749808"/>
+          </a:xfrm>
+          <a:prstGeom prst="rect">
+            <a:avLst/>
+          </a:prstGeom>
+          <a:noFill/>
+          <a:ln/>
+        </p:spPr>
+        <p:txBody>
+          <a:bodyPr wrap="square" lIns="0" tIns="0" rIns="0" bIns="0" rtlCol="0" anchor="t"/>
           <a:lstStyle/>
           <a:p>
             <a:pPr rtl="1" algn="r" indent="0" marL="0">
               <a:buNone/>
             </a:pPr>
             <a:r>
-              <a:rPr lang="en-US" sz="2600" b="1" dirty="0">
-                <a:solidFill>
-                  <a:srgbClr val="0B0B0B"/>
-                </a:solidFill>
+              <a:rPr lang="ar-AE" altLang="en-US" sz="2600" b="1" dirty="0">
+                <a:solidFill>
+                  <a:schemeClr val="tx1"/>
+                </a:solidFill>
+                <a:latin typeface="Cambria" pitchFamily="34" charset="0"/>
+                <a:ea typeface="Cambria" pitchFamily="34" charset="-122"/>
+                <a:cs typeface="Cambria" pitchFamily="34" charset="-120"/>
               </a:rPr>
               <a:t>لماذا نجتمع اليوم</a:t>
             </a:r>
-            <a:endParaRPr lang="en-US" sz="2600" dirty="0"/>
+            <a:endParaRPr lang="ar-AE" sz="2600" dirty="0"/>
           </a:p>
         </p:txBody>
       </p:sp>
@@ -3296,11 +3033,11 @@
             <a:avLst/>
           </a:prstGeom>
           <a:solidFill>
-            <a:srgbClr val="0B0B0B"/>
+            <a:srgbClr val="0E2238"/>
           </a:solidFill>
           <a:ln w="12700">
             <a:solidFill>
-              <a:srgbClr val="0B0B0B"/>
+              <a:srgbClr val="0E2238"/>
             </a:solidFill>
             <a:prstDash val="solid"/>
           </a:ln>
@@ -3339,7 +3076,7 @@
         <p:spPr>
           <a:xfrm>
             <a:off x="5715000" y="2103120"/>
-            <a:ext cx="2651760" cy="914400"/>
+            <a:ext cx="2651760" cy="713232"/>
           </a:xfrm>
           <a:prstGeom prst="rect">
             <a:avLst/>
@@ -3377,8 +3114,8 @@
         </p:nvSpPr>
         <p:spPr>
           <a:xfrm>
-            <a:off x="5715000" y="3017520"/>
-            <a:ext cx="2651760" cy="1280160"/>
+            <a:off x="5715000" y="2862072"/>
+            <a:ext cx="2651760" cy="1481328"/>
           </a:xfrm>
           <a:prstGeom prst="rect">
             <a:avLst/>
@@ -3394,14 +3131,14 @@
               <a:buNone/>
             </a:pPr>
             <a:r>
-              <a:rPr lang="ar-AE" altLang="en-US" sz="1150" dirty="0">
+              <a:rPr lang="ar-AE" altLang="en-US" sz="1100" dirty="0">
                 <a:solidFill>
                   <a:schemeClr val="bg2"/>
                 </a:solidFill>
               </a:rPr>
               <a:t>نبني معكم خدمة حماية متكاملة للمستثمر العقاري، تصبح جزءاً من قيمة ما تقدمونه لعملائكم.</a:t>
             </a:r>
-            <a:endParaRPr lang="ar-AE" sz="1150" dirty="0"/>
+            <a:endParaRPr lang="ar-AE" sz="1100" dirty="0"/>
           </a:p>
         </p:txBody>
       </p:sp>
@@ -3526,6 +3263,36 @@
               <a:t>شريك قانوني متخصص يتولى الجانب القانوني كاملاً، بينما تحتفظون أنتم بالعلاقة مع العميل.</a:t>
             </a:r>
             <a:endParaRPr lang="ar-AE" sz="1300" dirty="0"/>
+          </a:p>
+        </p:txBody>
+      </p:sp>
+      <p:sp>
+        <p:nvSpPr>
+          <p:cNvPr id="9" name="Text 0"/>
+          <p:cNvSpPr/>
+          <p:nvPr>
+            <p:ph idx="101" type="title" hasCustomPrompt="1"/>
+          </p:nvPr>
+        </p:nvSpPr>
+        <p:spPr>
+          <a:xfrm>
+            <a:off x="457200" y="420624"/>
+            <a:ext cx="8229600" cy="731520"/>
+          </a:xfrm>
+          <a:prstGeom prst="rect">
+            <a:avLst/>
+          </a:prstGeom>
+          <a:noFill/>
+          <a:ln/>
+        </p:spPr>
+        <p:txBody>
+          <a:bodyPr wrap="square" lIns="0" tIns="0" rIns="0" bIns="0" rtlCol="0" anchor="t"/>
+          <a:lstStyle/>
+          <a:p>
+            <a:pPr algn="r" indent="0" marL="0">
+              <a:buNone/>
+            </a:pPr>
+            <a:endParaRPr lang="en-US" sz="2600" dirty="0"/>
           </a:p>
         </p:txBody>
       </p:sp>
@@ -3559,7 +3326,7 @@
             <a:lvl1pPr>
               <a:defRPr sz="900">
                 <a:solidFill>
-                  <a:srgbClr val="6B6F76"/>
+                  <a:srgbClr val="6E7B88"/>
                 </a:solidFill>
               </a:defRPr>
             </a:lvl1pPr>
@@ -3654,7 +3421,7 @@
           </a:prstGeom>
           <a:ln w="9525">
             <a:solidFill>
-              <a:srgbClr val="B08D57"/>
+              <a:srgbClr val="B5723B"/>
             </a:solidFill>
             <a:prstDash val="solid"/>
           </a:ln>
@@ -3771,7 +3538,7 @@
           </a:prstGeom>
           <a:ln w="9525">
             <a:solidFill>
-              <a:srgbClr val="B08D57"/>
+              <a:srgbClr val="B5723B"/>
             </a:solidFill>
             <a:prstDash val="solid"/>
           </a:ln>
@@ -3888,7 +3655,7 @@
           </a:prstGeom>
           <a:ln w="9525">
             <a:solidFill>
-              <a:srgbClr val="B08D57"/>
+              <a:srgbClr val="B5723B"/>
             </a:solidFill>
             <a:prstDash val="solid"/>
           </a:ln>
@@ -4005,7 +3772,7 @@
           </a:prstGeom>
           <a:ln w="9525">
             <a:solidFill>
-              <a:srgbClr val="B08D57"/>
+              <a:srgbClr val="B5723B"/>
             </a:solidFill>
             <a:prstDash val="solid"/>
           </a:ln>
@@ -4136,7 +3903,7 @@
             <a:lvl1pPr>
               <a:defRPr sz="900">
                 <a:solidFill>
-                  <a:srgbClr val="D8C39A"/>
+                  <a:srgbClr val="D9B38C"/>
                 </a:solidFill>
               </a:defRPr>
             </a:lvl1pPr>
@@ -4178,39 +3945,40 @@
       </p:grpSpPr>
       <p:sp>
         <p:nvSpPr>
-          <p:cNvPr id="2" name="Text 3"/>
-          <p:cNvSpPr/>
-          <p:nvPr>
-            <p:ph idx="103" type="title" hasCustomPrompt="1"/>
-          </p:nvPr>
-        </p:nvSpPr>
-        <p:spPr>
-          <a:xfrm>
-            <a:off x="457200" y="347472"/>
-            <a:ext cx="8229600" cy="685800"/>
-          </a:xfrm>
-          <a:prstGeom prst="rect">
-            <a:avLst/>
-          </a:prstGeom>
-          <a:noFill/>
-          <a:ln/>
-        </p:spPr>
-        <p:txBody>
-          <a:bodyPr wrap="square" lIns="0" tIns="0" rIns="0" bIns="0" rtlCol="0" anchor="ctr"/>
+          <p:cNvPr id="2" name="Text 0"/>
+          <p:cNvSpPr txBox="1"/>
+          <p:nvPr/>
+        </p:nvSpPr>
+        <p:spPr>
+          <a:xfrm>
+            <a:off x="457200" y="402336"/>
+            <a:ext cx="8229600" cy="749808"/>
+          </a:xfrm>
+          <a:prstGeom prst="rect">
+            <a:avLst/>
+          </a:prstGeom>
+          <a:noFill/>
+          <a:ln/>
+        </p:spPr>
+        <p:txBody>
+          <a:bodyPr wrap="square" lIns="0" tIns="0" rIns="0" bIns="0" rtlCol="0" anchor="t"/>
           <a:lstStyle/>
           <a:p>
             <a:pPr rtl="1" algn="r" indent="0" marL="0">
               <a:buNone/>
             </a:pPr>
             <a:r>
-              <a:rPr lang="en-US" sz="2600" b="1" dirty="0">
-                <a:solidFill>
-                  <a:srgbClr val="0B0B0B"/>
-                </a:solidFill>
+              <a:rPr lang="ar-AE" altLang="en-US" sz="2600" b="1" dirty="0">
+                <a:solidFill>
+                  <a:schemeClr val="tx1"/>
+                </a:solidFill>
+                <a:latin typeface="Cambria" pitchFamily="34" charset="0"/>
+                <a:ea typeface="Cambria" pitchFamily="34" charset="-122"/>
+                <a:cs typeface="Cambria" pitchFamily="34" charset="-120"/>
               </a:rPr>
               <a:t>ما الذي يحصل عليه عميلكم</a:t>
             </a:r>
-            <a:endParaRPr lang="en-US" sz="2600" dirty="0"/>
+            <a:endParaRPr lang="ar-AE" sz="2600" dirty="0"/>
           </a:p>
         </p:txBody>
       </p:sp>
@@ -4265,11 +4033,11 @@
             <a:avLst/>
           </a:prstGeom>
           <a:solidFill>
-            <a:srgbClr val="F4F1EA"/>
+            <a:srgbClr val="F4F1EB"/>
           </a:solidFill>
           <a:ln w="12700">
             <a:solidFill>
-              <a:srgbClr val="F4F1EA"/>
+              <a:srgbClr val="F4F1EB"/>
             </a:solidFill>
             <a:prstDash val="solid"/>
           </a:ln>
@@ -4370,11 +4138,11 @@
             <a:avLst/>
           </a:prstGeom>
           <a:solidFill>
-            <a:srgbClr val="F4F1EA"/>
+            <a:srgbClr val="F4F1EB"/>
           </a:solidFill>
           <a:ln w="12700">
             <a:solidFill>
-              <a:srgbClr val="F4F1EA"/>
+              <a:srgbClr val="F4F1EB"/>
             </a:solidFill>
             <a:prstDash val="solid"/>
           </a:ln>
@@ -4475,11 +4243,11 @@
             <a:avLst/>
           </a:prstGeom>
           <a:solidFill>
-            <a:srgbClr val="F4F1EA"/>
+            <a:srgbClr val="F4F1EB"/>
           </a:solidFill>
           <a:ln w="12700">
             <a:solidFill>
-              <a:srgbClr val="F4F1EA"/>
+              <a:srgbClr val="F4F1EB"/>
             </a:solidFill>
             <a:prstDash val="solid"/>
           </a:ln>
@@ -4580,11 +4348,11 @@
             <a:avLst/>
           </a:prstGeom>
           <a:solidFill>
-            <a:srgbClr val="F4F1EA"/>
+            <a:srgbClr val="F4F1EB"/>
           </a:solidFill>
           <a:ln w="12700">
             <a:solidFill>
-              <a:srgbClr val="F4F1EA"/>
+              <a:srgbClr val="F4F1EB"/>
             </a:solidFill>
             <a:prstDash val="solid"/>
           </a:ln>
@@ -4672,6 +4440,36 @@
       </p:sp>
       <p:sp>
         <p:nvSpPr>
+          <p:cNvPr id="16" name="Text 0"/>
+          <p:cNvSpPr/>
+          <p:nvPr>
+            <p:ph idx="101" type="title" hasCustomPrompt="1"/>
+          </p:nvPr>
+        </p:nvSpPr>
+        <p:spPr>
+          <a:xfrm>
+            <a:off x="457200" y="420624"/>
+            <a:ext cx="8229600" cy="731520"/>
+          </a:xfrm>
+          <a:prstGeom prst="rect">
+            <a:avLst/>
+          </a:prstGeom>
+          <a:noFill/>
+          <a:ln/>
+        </p:spPr>
+        <p:txBody>
+          <a:bodyPr wrap="square" lIns="0" tIns="0" rIns="0" bIns="0" rtlCol="0" anchor="t"/>
+          <a:lstStyle/>
+          <a:p>
+            <a:pPr algn="r" indent="0" marL="0">
+              <a:buNone/>
+            </a:pPr>
+            <a:endParaRPr lang="en-US" sz="2600" dirty="0"/>
+          </a:p>
+        </p:txBody>
+      </p:sp>
+      <p:sp>
+        <p:nvSpPr>
           <p:cNvPr id="25" name="Slide Number Placeholder 0"/>
           <p:cNvSpPr>
             <a:spLocks noGrp="1"/>
@@ -4700,7 +4498,7 @@
             <a:lvl1pPr>
               <a:defRPr sz="900">
                 <a:solidFill>
-                  <a:srgbClr val="6B6F76"/>
+                  <a:srgbClr val="6E7B88"/>
                 </a:solidFill>
               </a:defRPr>
             </a:lvl1pPr>
@@ -4742,39 +4540,40 @@
       </p:grpSpPr>
       <p:sp>
         <p:nvSpPr>
-          <p:cNvPr id="2" name="Text 3"/>
-          <p:cNvSpPr/>
-          <p:nvPr>
-            <p:ph idx="103" type="title" hasCustomPrompt="1"/>
-          </p:nvPr>
-        </p:nvSpPr>
-        <p:spPr>
-          <a:xfrm>
-            <a:off x="457200" y="347472"/>
-            <a:ext cx="8229600" cy="685800"/>
-          </a:xfrm>
-          <a:prstGeom prst="rect">
-            <a:avLst/>
-          </a:prstGeom>
-          <a:noFill/>
-          <a:ln/>
-        </p:spPr>
-        <p:txBody>
-          <a:bodyPr wrap="square" lIns="0" tIns="0" rIns="0" bIns="0" rtlCol="0" anchor="ctr"/>
+          <p:cNvPr id="2" name="Text 0"/>
+          <p:cNvSpPr txBox="1"/>
+          <p:nvPr/>
+        </p:nvSpPr>
+        <p:spPr>
+          <a:xfrm>
+            <a:off x="457200" y="402336"/>
+            <a:ext cx="8229600" cy="749808"/>
+          </a:xfrm>
+          <a:prstGeom prst="rect">
+            <a:avLst/>
+          </a:prstGeom>
+          <a:noFill/>
+          <a:ln/>
+        </p:spPr>
+        <p:txBody>
+          <a:bodyPr wrap="square" lIns="0" tIns="0" rIns="0" bIns="0" rtlCol="0" anchor="t"/>
           <a:lstStyle/>
           <a:p>
             <a:pPr rtl="1" algn="r" indent="0" marL="0">
               <a:buNone/>
             </a:pPr>
             <a:r>
-              <a:rPr lang="en-US" sz="2600" b="1" dirty="0">
-                <a:solidFill>
-                  <a:srgbClr val="0B0B0B"/>
-                </a:solidFill>
+              <a:rPr lang="ar-AE" altLang="en-US" sz="2600" b="1" dirty="0">
+                <a:solidFill>
+                  <a:schemeClr val="tx1"/>
+                </a:solidFill>
+                <a:latin typeface="Cambria" pitchFamily="34" charset="0"/>
+                <a:ea typeface="Cambria" pitchFamily="34" charset="-122"/>
+                <a:cs typeface="Cambria" pitchFamily="34" charset="-120"/>
               </a:rPr>
               <a:t>ما الذي تكسبه شركتكم</a:t>
             </a:r>
-            <a:endParaRPr lang="en-US" sz="2600" dirty="0"/>
+            <a:endParaRPr lang="ar-AE" sz="2600" dirty="0"/>
           </a:p>
         </p:txBody>
       </p:sp>
@@ -4829,11 +4628,11 @@
             <a:avLst/>
           </a:prstGeom>
           <a:solidFill>
-            <a:srgbClr val="F4F1EA"/>
+            <a:srgbClr val="F4F1EB"/>
           </a:solidFill>
           <a:ln w="12700">
             <a:solidFill>
-              <a:srgbClr val="F4F1EA"/>
+              <a:srgbClr val="F4F1EB"/>
             </a:solidFill>
             <a:prstDash val="solid"/>
           </a:ln>
@@ -4949,11 +4748,11 @@
             <a:avLst/>
           </a:prstGeom>
           <a:solidFill>
-            <a:srgbClr val="F4F1EA"/>
+            <a:srgbClr val="F4F1EB"/>
           </a:solidFill>
           <a:ln w="12700">
             <a:solidFill>
-              <a:srgbClr val="F4F1EA"/>
+              <a:srgbClr val="F4F1EB"/>
             </a:solidFill>
             <a:prstDash val="solid"/>
           </a:ln>
@@ -5069,11 +4868,11 @@
             <a:avLst/>
           </a:prstGeom>
           <a:solidFill>
-            <a:srgbClr val="F4F1EA"/>
+            <a:srgbClr val="F4F1EB"/>
           </a:solidFill>
           <a:ln w="12700">
             <a:solidFill>
-              <a:srgbClr val="F4F1EA"/>
+              <a:srgbClr val="F4F1EB"/>
             </a:solidFill>
             <a:prstDash val="solid"/>
           </a:ln>
@@ -5189,11 +4988,11 @@
             <a:avLst/>
           </a:prstGeom>
           <a:solidFill>
-            <a:srgbClr val="F4F1EA"/>
+            <a:srgbClr val="F4F1EB"/>
           </a:solidFill>
           <a:ln w="12700">
             <a:solidFill>
-              <a:srgbClr val="F4F1EA"/>
+              <a:srgbClr val="F4F1EB"/>
             </a:solidFill>
             <a:prstDash val="solid"/>
           </a:ln>
@@ -5291,6 +5090,36 @@
               <a:t>هيكل إحالة واضح ومنظم يحوّل الخدمة إلى مصدر دخل منتظم.</a:t>
             </a:r>
             <a:endParaRPr lang="ar-AE" sz="1400" dirty="0"/>
+          </a:p>
+        </p:txBody>
+      </p:sp>
+      <p:sp>
+        <p:nvSpPr>
+          <p:cNvPr id="16" name="Text 0"/>
+          <p:cNvSpPr/>
+          <p:nvPr>
+            <p:ph idx="101" type="title" hasCustomPrompt="1"/>
+          </p:nvPr>
+        </p:nvSpPr>
+        <p:spPr>
+          <a:xfrm>
+            <a:off x="457200" y="420624"/>
+            <a:ext cx="8229600" cy="731520"/>
+          </a:xfrm>
+          <a:prstGeom prst="rect">
+            <a:avLst/>
+          </a:prstGeom>
+          <a:noFill/>
+          <a:ln/>
+        </p:spPr>
+        <p:txBody>
+          <a:bodyPr wrap="square" lIns="0" tIns="0" rIns="0" bIns="0" rtlCol="0" anchor="t"/>
+          <a:lstStyle/>
+          <a:p>
+            <a:pPr algn="r" indent="0" marL="0">
+              <a:buNone/>
+            </a:pPr>
+            <a:endParaRPr lang="en-US" sz="2600" dirty="0"/>
           </a:p>
         </p:txBody>
       </p:sp>
@@ -5324,7 +5153,7 @@
             <a:lvl1pPr>
               <a:defRPr sz="900">
                 <a:solidFill>
-                  <a:srgbClr val="6B6F76"/>
+                  <a:srgbClr val="6E7B88"/>
                 </a:solidFill>
               </a:defRPr>
             </a:lvl1pPr>
@@ -5366,39 +5195,40 @@
       </p:grpSpPr>
       <p:sp>
         <p:nvSpPr>
-          <p:cNvPr id="2" name="Text 3"/>
-          <p:cNvSpPr/>
-          <p:nvPr>
-            <p:ph idx="103" type="title" hasCustomPrompt="1"/>
-          </p:nvPr>
-        </p:nvSpPr>
-        <p:spPr>
-          <a:xfrm>
-            <a:off x="457200" y="347472"/>
-            <a:ext cx="8229600" cy="685800"/>
-          </a:xfrm>
-          <a:prstGeom prst="rect">
-            <a:avLst/>
-          </a:prstGeom>
-          <a:noFill/>
-          <a:ln/>
-        </p:spPr>
-        <p:txBody>
-          <a:bodyPr wrap="square" lIns="0" tIns="0" rIns="0" bIns="0" rtlCol="0" anchor="ctr"/>
+          <p:cNvPr id="2" name="Text 0"/>
+          <p:cNvSpPr txBox="1"/>
+          <p:nvPr/>
+        </p:nvSpPr>
+        <p:spPr>
+          <a:xfrm>
+            <a:off x="457200" y="402336"/>
+            <a:ext cx="8229600" cy="749808"/>
+          </a:xfrm>
+          <a:prstGeom prst="rect">
+            <a:avLst/>
+          </a:prstGeom>
+          <a:noFill/>
+          <a:ln/>
+        </p:spPr>
+        <p:txBody>
+          <a:bodyPr wrap="square" lIns="0" tIns="0" rIns="0" bIns="0" rtlCol="0" anchor="t"/>
           <a:lstStyle/>
           <a:p>
             <a:pPr rtl="1" algn="r" indent="0" marL="0">
               <a:buNone/>
             </a:pPr>
             <a:r>
-              <a:rPr lang="en-US" sz="2600" b="1" dirty="0">
-                <a:solidFill>
-                  <a:srgbClr val="0B0B0B"/>
-                </a:solidFill>
+              <a:rPr lang="ar-AE" altLang="en-US" sz="2600" b="1" dirty="0">
+                <a:solidFill>
+                  <a:schemeClr val="tx1"/>
+                </a:solidFill>
+                <a:latin typeface="Cambria" pitchFamily="34" charset="0"/>
+                <a:ea typeface="Cambria" pitchFamily="34" charset="-122"/>
+                <a:cs typeface="Cambria" pitchFamily="34" charset="-120"/>
               </a:rPr>
               <a:t>العملية بسيطة جداً</a:t>
             </a:r>
-            <a:endParaRPr lang="en-US" sz="2600" dirty="0"/>
+            <a:endParaRPr lang="ar-AE" sz="2600" dirty="0"/>
           </a:p>
         </p:txBody>
       </p:sp>
@@ -5455,7 +5285,7 @@
           <a:noFill/>
           <a:ln w="9525">
             <a:solidFill>
-              <a:srgbClr val="D8C39A"/>
+              <a:srgbClr val="D9B38C"/>
             </a:solidFill>
             <a:prstDash val="solid"/>
           </a:ln>
@@ -5476,11 +5306,11 @@
             <a:avLst/>
           </a:prstGeom>
           <a:solidFill>
-            <a:srgbClr val="0B0B0B"/>
+            <a:srgbClr val="0E2238"/>
           </a:solidFill>
           <a:ln w="12700">
             <a:solidFill>
-              <a:srgbClr val="B08D57"/>
+              <a:srgbClr val="B5723B"/>
             </a:solidFill>
             <a:prstDash val="solid"/>
           </a:ln>
@@ -5612,11 +5442,11 @@
             <a:avLst/>
           </a:prstGeom>
           <a:solidFill>
-            <a:srgbClr val="0B0B0B"/>
+            <a:srgbClr val="0E2238"/>
           </a:solidFill>
           <a:ln w="12700">
             <a:solidFill>
-              <a:srgbClr val="B08D57"/>
+              <a:srgbClr val="B5723B"/>
             </a:solidFill>
             <a:prstDash val="solid"/>
           </a:ln>
@@ -5748,11 +5578,11 @@
             <a:avLst/>
           </a:prstGeom>
           <a:solidFill>
-            <a:srgbClr val="0B0B0B"/>
+            <a:srgbClr val="0E2238"/>
           </a:solidFill>
           <a:ln w="12700">
             <a:solidFill>
-              <a:srgbClr val="B08D57"/>
+              <a:srgbClr val="B5723B"/>
             </a:solidFill>
             <a:prstDash val="solid"/>
           </a:ln>
@@ -5884,11 +5714,11 @@
             <a:avLst/>
           </a:prstGeom>
           <a:solidFill>
-            <a:srgbClr val="0B0B0B"/>
+            <a:srgbClr val="0E2238"/>
           </a:solidFill>
           <a:ln w="12700">
             <a:solidFill>
-              <a:srgbClr val="B08D57"/>
+              <a:srgbClr val="B5723B"/>
             </a:solidFill>
             <a:prstDash val="solid"/>
           </a:ln>
@@ -6002,6 +5832,36 @@
               <a:t>تقرير شهري، وتسوية العمولة وفق الاتفاقية.</a:t>
             </a:r>
             <a:endParaRPr lang="ar-AE" sz="1050" dirty="0"/>
+          </a:p>
+        </p:txBody>
+      </p:sp>
+      <p:sp>
+        <p:nvSpPr>
+          <p:cNvPr id="21" name="Text 0"/>
+          <p:cNvSpPr/>
+          <p:nvPr>
+            <p:ph idx="101" type="title" hasCustomPrompt="1"/>
+          </p:nvPr>
+        </p:nvSpPr>
+        <p:spPr>
+          <a:xfrm>
+            <a:off x="457200" y="420624"/>
+            <a:ext cx="8229600" cy="731520"/>
+          </a:xfrm>
+          <a:prstGeom prst="rect">
+            <a:avLst/>
+          </a:prstGeom>
+          <a:noFill/>
+          <a:ln/>
+        </p:spPr>
+        <p:txBody>
+          <a:bodyPr wrap="square" lIns="0" tIns="0" rIns="0" bIns="0" rtlCol="0" anchor="t"/>
+          <a:lstStyle/>
+          <a:p>
+            <a:pPr algn="r" indent="0" marL="0">
+              <a:buNone/>
+            </a:pPr>
+            <a:endParaRPr lang="en-US" sz="2600" dirty="0"/>
           </a:p>
         </p:txBody>
       </p:sp>
@@ -6035,7 +5895,7 @@
             <a:lvl1pPr>
               <a:defRPr sz="900">
                 <a:solidFill>
-                  <a:srgbClr val="6B6F76"/>
+                  <a:srgbClr val="6E7B88"/>
                 </a:solidFill>
               </a:defRPr>
             </a:lvl1pPr>
@@ -6077,39 +5937,40 @@
       </p:grpSpPr>
       <p:sp>
         <p:nvSpPr>
-          <p:cNvPr id="2" name="Text 3"/>
-          <p:cNvSpPr/>
-          <p:nvPr>
-            <p:ph idx="103" type="title" hasCustomPrompt="1"/>
-          </p:nvPr>
-        </p:nvSpPr>
-        <p:spPr>
-          <a:xfrm>
-            <a:off x="457200" y="347472"/>
-            <a:ext cx="8229600" cy="685800"/>
-          </a:xfrm>
-          <a:prstGeom prst="rect">
-            <a:avLst/>
-          </a:prstGeom>
-          <a:noFill/>
-          <a:ln/>
-        </p:spPr>
-        <p:txBody>
-          <a:bodyPr wrap="square" lIns="0" tIns="0" rIns="0" bIns="0" rtlCol="0" anchor="ctr"/>
+          <p:cNvPr id="2" name="Text 0"/>
+          <p:cNvSpPr txBox="1"/>
+          <p:nvPr/>
+        </p:nvSpPr>
+        <p:spPr>
+          <a:xfrm>
+            <a:off x="457200" y="402336"/>
+            <a:ext cx="8229600" cy="749808"/>
+          </a:xfrm>
+          <a:prstGeom prst="rect">
+            <a:avLst/>
+          </a:prstGeom>
+          <a:noFill/>
+          <a:ln/>
+        </p:spPr>
+        <p:txBody>
+          <a:bodyPr wrap="square" lIns="0" tIns="0" rIns="0" bIns="0" rtlCol="0" anchor="t"/>
           <a:lstStyle/>
           <a:p>
             <a:pPr rtl="1" algn="r" indent="0" marL="0">
               <a:buNone/>
             </a:pPr>
             <a:r>
-              <a:rPr lang="en-US" sz="2600" b="1" dirty="0">
-                <a:solidFill>
-                  <a:srgbClr val="0B0B0B"/>
-                </a:solidFill>
+              <a:rPr lang="ar-AE" altLang="en-US" sz="2600" b="1" dirty="0">
+                <a:solidFill>
+                  <a:schemeClr val="tx1"/>
+                </a:solidFill>
+                <a:latin typeface="Cambria" pitchFamily="34" charset="0"/>
+                <a:ea typeface="Cambria" pitchFamily="34" charset="-122"/>
+                <a:cs typeface="Cambria" pitchFamily="34" charset="-120"/>
               </a:rPr>
               <a:t>دوركم ودورنا</a:t>
             </a:r>
-            <a:endParaRPr lang="en-US" sz="2600" dirty="0"/>
+            <a:endParaRPr lang="ar-AE" sz="2600" dirty="0"/>
           </a:p>
         </p:txBody>
       </p:sp>
@@ -6164,11 +6025,11 @@
             <a:avLst/>
           </a:prstGeom>
           <a:solidFill>
-            <a:srgbClr val="0B0B0B"/>
+            <a:srgbClr val="0E2238"/>
           </a:solidFill>
           <a:ln w="12700">
             <a:solidFill>
-              <a:srgbClr val="0B0B0B"/>
+              <a:srgbClr val="0E2238"/>
             </a:solidFill>
             <a:prstDash val="solid"/>
           </a:ln>
@@ -6225,11 +6086,11 @@
             <a:avLst/>
           </a:prstGeom>
           <a:solidFill>
-            <a:srgbClr val="F4F1EA"/>
+            <a:srgbClr val="F4F1EB"/>
           </a:solidFill>
           <a:ln w="12700">
             <a:solidFill>
-              <a:srgbClr val="F4F1EA"/>
+              <a:srgbClr val="F4F1EB"/>
             </a:solidFill>
             <a:prstDash val="solid"/>
           </a:ln>
@@ -6344,11 +6205,11 @@
             <a:avLst/>
           </a:prstGeom>
           <a:solidFill>
-            <a:srgbClr val="B08D57"/>
+            <a:srgbClr val="B5723B"/>
           </a:solidFill>
           <a:ln w="12700">
             <a:solidFill>
-              <a:srgbClr val="B08D57"/>
+              <a:srgbClr val="B5723B"/>
             </a:solidFill>
             <a:prstDash val="solid"/>
           </a:ln>
@@ -6405,11 +6266,11 @@
             <a:avLst/>
           </a:prstGeom>
           <a:solidFill>
-            <a:srgbClr val="F4F1EA"/>
+            <a:srgbClr val="F4F1EB"/>
           </a:solidFill>
           <a:ln w="12700">
             <a:solidFill>
-              <a:srgbClr val="F4F1EA"/>
+              <a:srgbClr val="F4F1EB"/>
             </a:solidFill>
             <a:prstDash val="solid"/>
           </a:ln>
@@ -6506,6 +6367,36 @@
               <a:t>خدمة بمستوى Concierge بأربع لغات</a:t>
             </a:r>
             <a:endParaRPr lang="ar-AE" sz="1100" dirty="0"/>
+          </a:p>
+        </p:txBody>
+      </p:sp>
+      <p:sp>
+        <p:nvSpPr>
+          <p:cNvPr id="12" name="Text 0"/>
+          <p:cNvSpPr/>
+          <p:nvPr>
+            <p:ph idx="101" type="title" hasCustomPrompt="1"/>
+          </p:nvPr>
+        </p:nvSpPr>
+        <p:spPr>
+          <a:xfrm>
+            <a:off x="457200" y="420624"/>
+            <a:ext cx="8229600" cy="731520"/>
+          </a:xfrm>
+          <a:prstGeom prst="rect">
+            <a:avLst/>
+          </a:prstGeom>
+          <a:noFill/>
+          <a:ln/>
+        </p:spPr>
+        <p:txBody>
+          <a:bodyPr wrap="square" lIns="0" tIns="0" rIns="0" bIns="0" rtlCol="0" anchor="t"/>
+          <a:lstStyle/>
+          <a:p>
+            <a:pPr algn="r" indent="0" marL="0">
+              <a:buNone/>
+            </a:pPr>
+            <a:endParaRPr lang="en-US" sz="2600" dirty="0"/>
           </a:p>
         </p:txBody>
       </p:sp>
@@ -6539,7 +6430,7 @@
             <a:lvl1pPr>
               <a:defRPr sz="900">
                 <a:solidFill>
-                  <a:srgbClr val="6B6F76"/>
+                  <a:srgbClr val="6E7B88"/>
                 </a:solidFill>
               </a:defRPr>
             </a:lvl1pPr>
@@ -6581,39 +6472,40 @@
       </p:grpSpPr>
       <p:sp>
         <p:nvSpPr>
-          <p:cNvPr id="2" name="Text 3"/>
-          <p:cNvSpPr/>
-          <p:nvPr>
-            <p:ph idx="103" type="title" hasCustomPrompt="1"/>
-          </p:nvPr>
-        </p:nvSpPr>
-        <p:spPr>
-          <a:xfrm>
-            <a:off x="457200" y="347472"/>
-            <a:ext cx="8229600" cy="685800"/>
-          </a:xfrm>
-          <a:prstGeom prst="rect">
-            <a:avLst/>
-          </a:prstGeom>
-          <a:noFill/>
-          <a:ln/>
-        </p:spPr>
-        <p:txBody>
-          <a:bodyPr wrap="square" lIns="0" tIns="0" rIns="0" bIns="0" rtlCol="0" anchor="ctr"/>
+          <p:cNvPr id="2" name="Text 0"/>
+          <p:cNvSpPr txBox="1"/>
+          <p:nvPr/>
+        </p:nvSpPr>
+        <p:spPr>
+          <a:xfrm>
+            <a:off x="457200" y="402336"/>
+            <a:ext cx="8229600" cy="749808"/>
+          </a:xfrm>
+          <a:prstGeom prst="rect">
+            <a:avLst/>
+          </a:prstGeom>
+          <a:noFill/>
+          <a:ln/>
+        </p:spPr>
+        <p:txBody>
+          <a:bodyPr wrap="square" lIns="0" tIns="0" rIns="0" bIns="0" rtlCol="0" anchor="t"/>
           <a:lstStyle/>
           <a:p>
             <a:pPr rtl="1" algn="r" indent="0" marL="0">
               <a:buNone/>
             </a:pPr>
             <a:r>
-              <a:rPr lang="en-US" sz="2600" b="1" dirty="0">
-                <a:solidFill>
-                  <a:srgbClr val="0B0B0B"/>
-                </a:solidFill>
+              <a:rPr lang="ar-AE" altLang="en-US" sz="2600" b="1" dirty="0">
+                <a:solidFill>
+                  <a:schemeClr val="tx1"/>
+                </a:solidFill>
+                <a:latin typeface="Cambria" pitchFamily="34" charset="0"/>
+                <a:ea typeface="Cambria" pitchFamily="34" charset="-122"/>
+                <a:cs typeface="Cambria" pitchFamily="34" charset="-120"/>
               </a:rPr>
               <a:t>نجهّزكم للانطلاق فوراً</a:t>
             </a:r>
-            <a:endParaRPr lang="en-US" sz="2600" dirty="0"/>
+            <a:endParaRPr lang="ar-AE" sz="2600" dirty="0"/>
           </a:p>
         </p:txBody>
       </p:sp>
@@ -6668,11 +6560,11 @@
             <a:avLst/>
           </a:prstGeom>
           <a:solidFill>
-            <a:srgbClr val="F4F1EA"/>
+            <a:srgbClr val="F4F1EB"/>
           </a:solidFill>
           <a:ln w="12700">
             <a:solidFill>
-              <a:srgbClr val="F4F1EA"/>
+              <a:srgbClr val="F4F1EB"/>
             </a:solidFill>
             <a:prstDash val="solid"/>
           </a:ln>
@@ -6773,11 +6665,11 @@
             <a:avLst/>
           </a:prstGeom>
           <a:solidFill>
-            <a:srgbClr val="F4F1EA"/>
+            <a:srgbClr val="F4F1EB"/>
           </a:solidFill>
           <a:ln w="12700">
             <a:solidFill>
-              <a:srgbClr val="F4F1EA"/>
+              <a:srgbClr val="F4F1EB"/>
             </a:solidFill>
             <a:prstDash val="solid"/>
           </a:ln>
@@ -6878,11 +6770,11 @@
             <a:avLst/>
           </a:prstGeom>
           <a:solidFill>
-            <a:srgbClr val="F4F1EA"/>
+            <a:srgbClr val="F4F1EB"/>
           </a:solidFill>
           <a:ln w="12700">
             <a:solidFill>
-              <a:srgbClr val="F4F1EA"/>
+              <a:srgbClr val="F4F1EB"/>
             </a:solidFill>
             <a:prstDash val="solid"/>
           </a:ln>
@@ -6983,11 +6875,11 @@
             <a:avLst/>
           </a:prstGeom>
           <a:solidFill>
-            <a:srgbClr val="F4F1EA"/>
+            <a:srgbClr val="F4F1EB"/>
           </a:solidFill>
           <a:ln w="12700">
             <a:solidFill>
-              <a:srgbClr val="F4F1EA"/>
+              <a:srgbClr val="F4F1EB"/>
             </a:solidFill>
             <a:prstDash val="solid"/>
           </a:ln>
@@ -7088,11 +6980,11 @@
             <a:avLst/>
           </a:prstGeom>
           <a:solidFill>
-            <a:srgbClr val="0B0B0B"/>
+            <a:srgbClr val="0E2238"/>
           </a:solidFill>
           <a:ln w="12700">
             <a:solidFill>
-              <a:srgbClr val="0B0B0B"/>
+              <a:srgbClr val="0E2238"/>
             </a:solidFill>
             <a:prstDash val="solid"/>
           </a:ln>
@@ -7114,7 +7006,7 @@
           </a:prstGeom>
           <a:ln w="9525">
             <a:solidFill>
-              <a:srgbClr val="B08D57"/>
+              <a:srgbClr val="B5723B"/>
             </a:solidFill>
             <a:prstDash val="solid"/>
           </a:ln>
@@ -7192,6 +7084,36 @@
               <a:t>بعد الحجز، أثناء توقيع عقد البيع (SPA)، بعد التملك، أو أثناء الحديث عن الاستثمار طويل الأجل.</a:t>
             </a:r>
             <a:endParaRPr lang="ar-AE" sz="1150" dirty="0"/>
+          </a:p>
+        </p:txBody>
+      </p:sp>
+      <p:sp>
+        <p:nvSpPr>
+          <p:cNvPr id="20" name="Text 0"/>
+          <p:cNvSpPr/>
+          <p:nvPr>
+            <p:ph idx="101" type="title" hasCustomPrompt="1"/>
+          </p:nvPr>
+        </p:nvSpPr>
+        <p:spPr>
+          <a:xfrm>
+            <a:off x="457200" y="420624"/>
+            <a:ext cx="8229600" cy="731520"/>
+          </a:xfrm>
+          <a:prstGeom prst="rect">
+            <a:avLst/>
+          </a:prstGeom>
+          <a:noFill/>
+          <a:ln/>
+        </p:spPr>
+        <p:txBody>
+          <a:bodyPr wrap="square" lIns="0" tIns="0" rIns="0" bIns="0" rtlCol="0" anchor="t"/>
+          <a:lstStyle/>
+          <a:p>
+            <a:pPr algn="r" indent="0" marL="0">
+              <a:buNone/>
+            </a:pPr>
+            <a:endParaRPr lang="en-US" sz="2600" dirty="0"/>
           </a:p>
         </p:txBody>
       </p:sp>
@@ -7225,7 +7147,7 @@
             <a:lvl1pPr>
               <a:defRPr sz="900">
                 <a:solidFill>
-                  <a:srgbClr val="6B6F76"/>
+                  <a:srgbClr val="6E7B88"/>
                 </a:solidFill>
               </a:defRPr>
             </a:lvl1pPr>
@@ -7267,39 +7189,40 @@
       </p:grpSpPr>
       <p:sp>
         <p:nvSpPr>
-          <p:cNvPr id="2" name="Text 3"/>
-          <p:cNvSpPr/>
-          <p:nvPr>
-            <p:ph idx="103" type="title" hasCustomPrompt="1"/>
-          </p:nvPr>
-        </p:nvSpPr>
-        <p:spPr>
-          <a:xfrm>
-            <a:off x="457200" y="347472"/>
-            <a:ext cx="8229600" cy="685800"/>
-          </a:xfrm>
-          <a:prstGeom prst="rect">
-            <a:avLst/>
-          </a:prstGeom>
-          <a:noFill/>
-          <a:ln/>
-        </p:spPr>
-        <p:txBody>
-          <a:bodyPr wrap="square" lIns="0" tIns="0" rIns="0" bIns="0" rtlCol="0" anchor="ctr"/>
+          <p:cNvPr id="2" name="Text 0"/>
+          <p:cNvSpPr txBox="1"/>
+          <p:nvPr/>
+        </p:nvSpPr>
+        <p:spPr>
+          <a:xfrm>
+            <a:off x="457200" y="402336"/>
+            <a:ext cx="8229600" cy="749808"/>
+          </a:xfrm>
+          <a:prstGeom prst="rect">
+            <a:avLst/>
+          </a:prstGeom>
+          <a:noFill/>
+          <a:ln/>
+        </p:spPr>
+        <p:txBody>
+          <a:bodyPr wrap="square" lIns="0" tIns="0" rIns="0" bIns="0" rtlCol="0" anchor="t"/>
           <a:lstStyle/>
           <a:p>
             <a:pPr rtl="1" algn="r" indent="0" marL="0">
               <a:buNone/>
             </a:pPr>
             <a:r>
-              <a:rPr lang="en-US" sz="2600" b="1" dirty="0">
-                <a:solidFill>
-                  <a:srgbClr val="0B0B0B"/>
-                </a:solidFill>
+              <a:rPr lang="ar-AE" altLang="en-US" sz="2600" b="1" dirty="0">
+                <a:solidFill>
+                  <a:schemeClr val="tx1"/>
+                </a:solidFill>
+                <a:latin typeface="Cambria" pitchFamily="34" charset="0"/>
+                <a:ea typeface="Cambria" pitchFamily="34" charset="-122"/>
+                <a:cs typeface="Cambria" pitchFamily="34" charset="-120"/>
               </a:rPr>
               <a:t>الاتفاقية باختصار</a:t>
             </a:r>
-            <a:endParaRPr lang="en-US" sz="2600" dirty="0"/>
+            <a:endParaRPr lang="ar-AE" sz="2600" dirty="0"/>
           </a:p>
         </p:txBody>
       </p:sp>
@@ -7354,11 +7277,11 @@
             <a:avLst/>
           </a:prstGeom>
           <a:solidFill>
-            <a:srgbClr val="F4F1EA"/>
+            <a:srgbClr val="F4F1EB"/>
           </a:solidFill>
           <a:ln w="12700">
             <a:solidFill>
-              <a:srgbClr val="F4F1EA"/>
+              <a:srgbClr val="F4F1EB"/>
             </a:solidFill>
             <a:prstDash val="solid"/>
           </a:ln>
@@ -7459,11 +7382,11 @@
             <a:avLst/>
           </a:prstGeom>
           <a:solidFill>
-            <a:srgbClr val="F4F1EA"/>
+            <a:srgbClr val="F4F1EB"/>
           </a:solidFill>
           <a:ln w="12700">
             <a:solidFill>
-              <a:srgbClr val="F4F1EA"/>
+              <a:srgbClr val="F4F1EB"/>
             </a:solidFill>
             <a:prstDash val="solid"/>
           </a:ln>
@@ -7564,11 +7487,11 @@
             <a:avLst/>
           </a:prstGeom>
           <a:solidFill>
-            <a:srgbClr val="F4F1EA"/>
+            <a:srgbClr val="F4F1EB"/>
           </a:solidFill>
           <a:ln w="12700">
             <a:solidFill>
-              <a:srgbClr val="F4F1EA"/>
+              <a:srgbClr val="F4F1EB"/>
             </a:solidFill>
             <a:prstDash val="solid"/>
           </a:ln>
@@ -7669,11 +7592,11 @@
             <a:avLst/>
           </a:prstGeom>
           <a:solidFill>
-            <a:srgbClr val="F4F1EA"/>
+            <a:srgbClr val="F4F1EB"/>
           </a:solidFill>
           <a:ln w="12700">
             <a:solidFill>
-              <a:srgbClr val="F4F1EA"/>
+              <a:srgbClr val="F4F1EB"/>
             </a:solidFill>
             <a:prstDash val="solid"/>
           </a:ln>
@@ -7774,11 +7697,11 @@
             <a:avLst/>
           </a:prstGeom>
           <a:solidFill>
-            <a:srgbClr val="F4F1EA"/>
+            <a:srgbClr val="F4F1EB"/>
           </a:solidFill>
           <a:ln w="12700">
             <a:solidFill>
-              <a:srgbClr val="F4F1EA"/>
+              <a:srgbClr val="F4F1EB"/>
             </a:solidFill>
             <a:prstDash val="solid"/>
           </a:ln>
@@ -7866,6 +7789,36 @@
       </p:sp>
       <p:sp>
         <p:nvSpPr>
+          <p:cNvPr id="19" name="Text 0"/>
+          <p:cNvSpPr/>
+          <p:nvPr>
+            <p:ph idx="101" type="title" hasCustomPrompt="1"/>
+          </p:nvPr>
+        </p:nvSpPr>
+        <p:spPr>
+          <a:xfrm>
+            <a:off x="457200" y="420624"/>
+            <a:ext cx="8229600" cy="731520"/>
+          </a:xfrm>
+          <a:prstGeom prst="rect">
+            <a:avLst/>
+          </a:prstGeom>
+          <a:noFill/>
+          <a:ln/>
+        </p:spPr>
+        <p:txBody>
+          <a:bodyPr wrap="square" lIns="0" tIns="0" rIns="0" bIns="0" rtlCol="0" anchor="t"/>
+          <a:lstStyle/>
+          <a:p>
+            <a:pPr algn="r" indent="0" marL="0">
+              <a:buNone/>
+            </a:pPr>
+            <a:endParaRPr lang="en-US" sz="2600" dirty="0"/>
+          </a:p>
+        </p:txBody>
+      </p:sp>
+      <p:sp>
+        <p:nvSpPr>
           <p:cNvPr id="25" name="Slide Number Placeholder 0"/>
           <p:cNvSpPr>
             <a:spLocks noGrp="1"/>
@@ -7894,7 +7847,7 @@
             <a:lvl1pPr>
               <a:defRPr sz="900">
                 <a:solidFill>
-                  <a:srgbClr val="6B6F76"/>
+                  <a:srgbClr val="6E7B88"/>
                 </a:solidFill>
               </a:defRPr>
             </a:lvl1pPr>
@@ -7918,47 +7871,47 @@
 </file>
 
 <file path=ppt/theme/theme1.xml><?xml version="1.0" encoding="utf-8"?>
-<a:theme xmlns:a="http://schemas.openxmlformats.org/drawingml/2006/main" name="RK Advocates">
+<a:theme xmlns:a="http://schemas.openxmlformats.org/drawingml/2006/main" name="Midnight Copper">
   <a:themeElements>
-    <a:clrScheme name="RK Advocates">
+    <a:clrScheme name="Midnight Copper">
       <a:dk1>
-        <a:srgbClr val="0B0B0B"/>
+        <a:srgbClr val="0E2238"/>
       </a:dk1>
       <a:lt1>
         <a:srgbClr val="FFFFFF"/>
       </a:lt1>
       <a:dk2>
-        <a:srgbClr val="2A2D33"/>
+        <a:srgbClr val="1F3A52"/>
       </a:dk2>
       <a:lt2>
-        <a:srgbClr val="F4F1EA"/>
+        <a:srgbClr val="F4F1EB"/>
       </a:lt2>
       <a:accent1>
-        <a:srgbClr val="B08D57"/>
+        <a:srgbClr val="B5723B"/>
       </a:accent1>
       <a:accent2>
-        <a:srgbClr val="D8C39A"/>
+        <a:srgbClr val="D9B38C"/>
       </a:accent2>
       <a:accent3>
-        <a:srgbClr val="6B6F76"/>
+        <a:srgbClr val="6E7B88"/>
       </a:accent3>
       <a:accent4>
-        <a:srgbClr val="8A6D3B"/>
+        <a:srgbClr val="8C5527"/>
       </a:accent4>
       <a:accent5>
-        <a:srgbClr val="E9E4DA"/>
+        <a:srgbClr val="E6E1D8"/>
       </a:accent5>
       <a:accent6>
-        <a:srgbClr val="15171B"/>
+        <a:srgbClr val="5B7A8C"/>
       </a:accent6>
       <a:hlink>
-        <a:srgbClr val="B08D57"/>
+        <a:srgbClr val="B5723B"/>
       </a:hlink>
       <a:folHlink>
-        <a:srgbClr val="8A6D3B"/>
+        <a:srgbClr val="8C5527"/>
       </a:folHlink>
     </a:clrScheme>
-    <a:fontScheme name="RK Advocates">
+    <a:fontScheme name="Midnight Copper">
       <a:majorFont>
         <a:latin typeface="Cambria"/>
         <a:ea typeface=""/>

</xml_diff>